<commit_message>
Add team to title slide
Team raghupatil9036 — Raghavendra S Patil, Pallavi C.

Co-Authored-By: Pallavi C <pallavichourad185@gmail.com>
</commit_message>
<xml_diff>
--- a/ET_AI_Hackathon_IKI.pptx
+++ b/ET_AI_Hackathon_IKI.pptx
@@ -1928,6 +1928,59 @@
         </p:nvSpPr>
         <p:spPr>
           <a:xfrm>
+            <a:off x="640080" y="5897880"/>
+            <a:ext cx="10972800" cy="274320"/>
+          </a:xfrm>
+          <a:prstGeom prst="rect">
+            <a:avLst/>
+          </a:prstGeom>
+          <a:noFill/>
+          <a:ln/>
+        </p:spPr>
+        <p:txBody>
+          <a:bodyPr wrap="square" lIns="0" tIns="0" rIns="0" bIns="0" rtlCol="0" anchor="ctr"/>
+          <a:lstStyle/>
+          <a:p>
+            <a:pPr indent="0" marL="0">
+              <a:buNone/>
+            </a:pPr>
+            <a:r>
+              <a:rPr lang="en-US" sz="1350" b="1" dirty="0">
+                <a:solidFill>
+                  <a:srgbClr val="E9EEF5"/>
+                </a:solidFill>
+                <a:latin typeface="Calibri" pitchFamily="34" charset="0"/>
+                <a:ea typeface="Calibri" pitchFamily="34" charset="-122"/>
+                <a:cs typeface="Calibri" pitchFamily="34" charset="-120"/>
+              </a:rPr>
+              <a:t>Team raghupatil9036</a:t>
+            </a:r>
+            <a:pPr indent="0" marL="0">
+              <a:buNone/>
+            </a:pPr>
+            <a:r>
+              <a:rPr lang="en-US" sz="1350" dirty="0">
+                <a:solidFill>
+                  <a:srgbClr val="97A4B3"/>
+                </a:solidFill>
+                <a:latin typeface="Calibri" pitchFamily="34" charset="0"/>
+                <a:ea typeface="Calibri" pitchFamily="34" charset="-122"/>
+                <a:cs typeface="Calibri" pitchFamily="34" charset="-120"/>
+              </a:rPr>
+              <a:t>   ·   Raghavendra S Patil   ·   Pallavi C</a:t>
+            </a:r>
+            <a:endParaRPr lang="en-US" sz="1350" dirty="0"/>
+          </a:p>
+        </p:txBody>
+      </p:sp>
+      <p:sp>
+        <p:nvSpPr>
+          <p:cNvPr id="9" name="Text 7"/>
+          <p:cNvSpPr/>
+          <p:nvPr/>
+        </p:nvSpPr>
+        <p:spPr>
+          <a:xfrm>
             <a:off x="640080" y="6217920"/>
             <a:ext cx="10972800" cy="274320"/>
           </a:xfrm>

</xml_diff>

<commit_message>
Final QA pass: update deck + fix full-site review findings
Deck: reflect multi-format ingestion, grounded answers, audit trail.

Backend:
- Fix concurrency race: ask() snapshots index/by_id/graph under lock so a
  live-ingestion reindex can't cause a KeyError 500
- Uploads persist ORIGINAL bytes so xlsx/pdf/eml re-parse correctly after restart
- Spreadsheet parsing handles ragged rows (zip_longest)

Frontend:
- Escape server/ingested-content fields across all render paths (graph tooltip,
  entity ids, doc ids/types, regulation/area, patterns, alerts, RCA) — closes
  defense-in-depth XSS via uploaded documents
- Guard graph label draw + Asset 360 partial responses; global async-error toast

17 tests pass; all 6 views verified; zero console errors.

Co-Authored-By: Pallavi C <pallavichourad185@gmail.com>
</commit_message>
<xml_diff>
--- a/ET_AI_Hackathon_IKI.pptx
+++ b/ET_AI_Hackathon_IKI.pptx
@@ -4202,7 +4202,7 @@
                 <a:ea typeface="Calibri" pitchFamily="34" charset="-122"/>
                 <a:cs typeface="Calibri" pitchFamily="34" charset="-120"/>
               </a:rPr>
-              <a:t>Reads any document, extracts entities, links them into a live graph</a:t>
+              <a:t>Reads PDF, spreadsheets &amp; email; extracts entities; links into a live graph</a:t>
             </a:r>
             <a:endParaRPr lang="en-US" sz="1250" dirty="0"/>
           </a:p>
@@ -5013,7 +5013,7 @@
                 <a:ea typeface="Calibri" pitchFamily="34" charset="-122"/>
                 <a:cs typeface="Calibri" pitchFamily="34" charset="-120"/>
               </a:rPr>
-              <a:t>Live upload · Asset 360 · audit exports · voice query · command palette</a:t>
+              <a:t>Multi-format ingest · grounded answers · audit trail · Asset 360 · voice · command palette</a:t>
             </a:r>
             <a:endParaRPr lang="en-US" sz="1250" dirty="0"/>
           </a:p>
@@ -5294,7 +5294,7 @@
                 <a:ea typeface="Calibri" pitchFamily="34" charset="-122"/>
                 <a:cs typeface="Calibri" pitchFamily="34" charset="-120"/>
               </a:rPr>
-              <a:t>PDF · scans · sheets</a:t>
+              <a:t>PDF · sheets · email</a:t>
             </a:r>
             <a:endParaRPr lang="en-US" sz="1100" dirty="0"/>
           </a:p>
@@ -7288,7 +7288,7 @@
                 <a:ea typeface="Calibri" pitchFamily="34" charset="-122"/>
                 <a:cs typeface="Calibri" pitchFamily="34" charset="-120"/>
               </a:rPr>
-              <a:t>Drop in a new document and it is entity-extracted, linked, and queryable instantly.</a:t>
+              <a:t>Drop in any format — PDF, spreadsheet or email — and it's entity-extracted, linked, and queryable instantly.</a:t>
             </a:r>
             <a:endParaRPr lang="en-US" sz="1250" dirty="0"/>
           </a:p>

</xml_diff>

<commit_message>
Add OCR scanned-document ingestion + expert feedback loop
OCR (Computer Vision / Document Intelligence — closes the brief's last gap):
- RapidOCR (pure-pip, offline, no system binary) reads scanned forms/photos
- Upload an image → OCR → entities extracted → linked into the graph
- Verified: a photo of a maintenance note yields PUMP-204/OISD/WO tags, 18 links

Feedback loop (captures retiring-workforce validation):
- 👍/👎 on any answer -> POST /api/feedback -> logged; tally on Overview audit panel

Deck + README + demo script updated. 19 tests pass (added OCR + feedback tests).

Co-Authored-By: Pallavi C <pallavichourad185@gmail.com>
</commit_message>
<xml_diff>
--- a/ET_AI_Hackathon_IKI.pptx
+++ b/ET_AI_Hackathon_IKI.pptx
@@ -4202,7 +4202,7 @@
                 <a:ea typeface="Calibri" pitchFamily="34" charset="-122"/>
                 <a:cs typeface="Calibri" pitchFamily="34" charset="-120"/>
               </a:rPr>
-              <a:t>Reads PDF, spreadsheets &amp; email; extracts entities; links into a live graph</a:t>
+              <a:t>Reads PDF, spreadsheets, email &amp; scanned images (OCR); links into a live graph</a:t>
             </a:r>
             <a:endParaRPr lang="en-US" sz="1250" dirty="0"/>
           </a:p>
@@ -5294,7 +5294,7 @@
                 <a:ea typeface="Calibri" pitchFamily="34" charset="-122"/>
                 <a:cs typeface="Calibri" pitchFamily="34" charset="-120"/>
               </a:rPr>
-              <a:t>PDF · sheets · email</a:t>
+              <a:t>PDF · sheets · email · scans (OCR)</a:t>
             </a:r>
             <a:endParaRPr lang="en-US" sz="1100" dirty="0"/>
           </a:p>
@@ -7288,7 +7288,7 @@
                 <a:ea typeface="Calibri" pitchFamily="34" charset="-122"/>
                 <a:cs typeface="Calibri" pitchFamily="34" charset="-120"/>
               </a:rPr>
-              <a:t>Drop in any format — PDF, spreadsheet or email — and it's entity-extracted, linked, and queryable instantly.</a:t>
+              <a:t>Drop in any format — PDF, spreadsheet, email, even a scanned photo (OCR) — entity-extracted, linked, queryable instantly.</a:t>
             </a:r>
             <a:endParaRPr lang="en-US" sz="1250" dirty="0"/>
           </a:p>

</xml_diff>

<commit_message>
Close roadmap gaps: P&ID digitisation, live SCADA fusion, industry cross-ref
- P&ID / drawing digitisation: OCR + layout analysis extracts equipment tags
  AND infers connections from their positions on the drawing (not just OCR text)
- Real-time operating conditions: live sensor feed (simulated SCADA) fused into
  the RCA agent + a live-updating conditions card + /api/sensors/{id}
- Lessons Learned now cross-references internal patterns against known industry
  failure modes (ISO/API/OISD references) via a curated external knowledge base

Deck + README updated. 22 tests pass (added P&ID, sensors/RCA, external-match).

Co-Authored-By: Pallavi C <pallavichourad185@gmail.com>
</commit_message>
<xml_diff>
--- a/ET_AI_Hackathon_IKI.pptx
+++ b/ET_AI_Hackathon_IKI.pptx
@@ -4202,7 +4202,7 @@
                 <a:ea typeface="Calibri" pitchFamily="34" charset="-122"/>
                 <a:cs typeface="Calibri" pitchFamily="34" charset="-120"/>
               </a:rPr>
-              <a:t>Reads PDF, spreadsheets, email &amp; scanned images (OCR); links into a live graph</a:t>
+              <a:t>Reads PDF, spreadsheets, email, scanned images &amp; P&amp;IDs (OCR + layout); links into a live graph</a:t>
             </a:r>
             <a:endParaRPr lang="en-US" sz="1250" dirty="0"/>
           </a:p>
@@ -4550,7 +4550,7 @@
                 <a:ea typeface="Calibri" pitchFamily="34" charset="-122"/>
                 <a:cs typeface="Calibri" pitchFamily="34" charset="-120"/>
               </a:rPr>
-              <a:t>Per-asset health, failure timeline, root cause &amp; predictive actions</a:t>
+              <a:t>Per-asset health, timeline &amp; root cause, fused with a live sensor feed</a:t>
             </a:r>
             <a:endParaRPr lang="en-US" sz="1250" dirty="0"/>
           </a:p>
@@ -4898,7 +4898,7 @@
                 <a:ea typeface="Calibri" pitchFamily="34" charset="-122"/>
                 <a:cs typeface="Calibri" pitchFamily="34" charset="-120"/>
               </a:rPr>
-              <a:t>Recurring failure patterns across the plant's whole history</a:t>
+              <a:t>Recurring failure patterns, matched to known industry failure modes</a:t>
             </a:r>
             <a:endParaRPr lang="en-US" sz="1250" dirty="0"/>
           </a:p>

</xml_diff>